<commit_message>
Add and align PDP strategy documents
</commit_message>
<xml_diff>
--- a/units/unit-b3-interactivity-state/02-keyboard-events/teacher/B3.1.2_Keyboard_Events_Revised.pptx
+++ b/units/unit-b3-interactivity-state/02-keyboard-events/teacher/B3.1.2_Keyboard_Events_Revised.pptx
@@ -2,19 +2,19 @@
 <file path=ppt/presentation.xml><?xml version="1.0" encoding="utf-8"?>
 <p:presentation xmlns:p="http://schemas.openxmlformats.org/presentationml/2006/main">
   <p:sldMasterIdLst>
-    <p:sldMasterId xmlns:r="http://schemas.openxmlformats.org/officeDocument/2006/relationships" id="2147483648" r:id="R9582bb58510d41d5"/>
+    <p:sldMasterId xmlns:r="http://schemas.openxmlformats.org/officeDocument/2006/relationships" id="2147483648" r:id="R2837e129c88a4395"/>
   </p:sldMasterIdLst>
   <p:notesMasterIdLst>
-    <p:notesMasterId xmlns:r="http://schemas.openxmlformats.org/officeDocument/2006/relationships" r:id="R1f2d51de4e1a42e4"/>
+    <p:notesMasterId xmlns:r="http://schemas.openxmlformats.org/officeDocument/2006/relationships" r:id="R88d10cac7f6a4ca4"/>
   </p:notesMasterIdLst>
   <p:sldIdLst>
-    <p:sldId xmlns:r="http://schemas.openxmlformats.org/officeDocument/2006/relationships" id="256" r:id="R15f17481a92844d4"/>
-    <p:sldId xmlns:r="http://schemas.openxmlformats.org/officeDocument/2006/relationships" id="257" r:id="Rf4483c2d71304f1f"/>
-    <p:sldId xmlns:r="http://schemas.openxmlformats.org/officeDocument/2006/relationships" id="258" r:id="R648f4f8318784fe1"/>
-    <p:sldId xmlns:r="http://schemas.openxmlformats.org/officeDocument/2006/relationships" id="259" r:id="R28431f8d4baa42aa"/>
-    <p:sldId xmlns:r="http://schemas.openxmlformats.org/officeDocument/2006/relationships" id="260" r:id="R7d25f226ac9044df"/>
-    <p:sldId xmlns:r="http://schemas.openxmlformats.org/officeDocument/2006/relationships" id="261" r:id="R4af0b5cbc8194622"/>
-    <p:sldId xmlns:r="http://schemas.openxmlformats.org/officeDocument/2006/relationships" id="262" r:id="R80290560325b48a5"/>
+    <p:sldId xmlns:r="http://schemas.openxmlformats.org/officeDocument/2006/relationships" id="256" r:id="R59ad2e1c37ae451d"/>
+    <p:sldId xmlns:r="http://schemas.openxmlformats.org/officeDocument/2006/relationships" id="257" r:id="Re01b6e088bf347be"/>
+    <p:sldId xmlns:r="http://schemas.openxmlformats.org/officeDocument/2006/relationships" id="258" r:id="R5047e8c9665c4d26"/>
+    <p:sldId xmlns:r="http://schemas.openxmlformats.org/officeDocument/2006/relationships" id="259" r:id="Reca54b5d2a024aa1"/>
+    <p:sldId xmlns:r="http://schemas.openxmlformats.org/officeDocument/2006/relationships" id="260" r:id="R65a2c381879b46a2"/>
+    <p:sldId xmlns:r="http://schemas.openxmlformats.org/officeDocument/2006/relationships" id="261" r:id="R611e1db2e0df4822"/>
+    <p:sldId xmlns:r="http://schemas.openxmlformats.org/officeDocument/2006/relationships" id="262" r:id="Rc0b14a5680e54995"/>
   </p:sldIdLst>
   <p:sldSz cx="12191675" cy="6858000"/>
   <p:notesSz cx="6858000" cy="9144000"/>
@@ -810,7 +810,7 @@
               <a:buNone/>
             </a:pPr>
             <a:r>
-              <a:t>7 minutes. Compare character keys with coded keys. For arrows, check key == CODED before reading keyCode; for letters, compare key directly.</a:t>
+              <a:t>7 minutes. Compare keyPressed (the held-state field) with keyPressed() (the callback). Trace one short press and one held key, then explain that operating-system key repeat can cause several callback calls during one physical hold.</a:t>
             </a:r>
             <a:endParaRPr/>
           </a:p>
@@ -935,7 +935,7 @@
               <a:buNone/>
             </a:pPr>
             <a:r>
-              <a:t>6 minutes. Add keyReleased() and keyTyped(). Explain that key repeat can generate repeated keyPressed events while a key is held, depending on the operating system.</a:t>
+              <a:t>6 minutes. Model held-state rendering in draw(). Trace key down, held, and key up. Emphasize that background(255) clears the previous frame so the shape disappears when keyPressed becomes false.</a:t>
             </a:r>
             <a:endParaRPr/>
           </a:p>
@@ -1060,7 +1060,7 @@
               <a:buNone/>
             </a:pPr>
             <a:r>
-              <a:t>13 minutes. Students add letter and arrow controls. Require a fallback branch so unexpected keys do not silently change state.</a:t>
+              <a:t>13 minutes. Students first change the printable character checked by the model, then build two distinct printable-key responses using two explicit if statements. They choose the keys and grayscale values, compile, run, and test both expected keys plus one unrelated key.</a:t>
             </a:r>
             <a:endParaRPr/>
           </a:p>
@@ -1185,7 +1185,52 @@
               <a:buNone/>
             </a:pPr>
             <a:r>
-              <a:t>3 minutes. Exit check: choose key or keyCode for three examples and justify each choice.</a:t>
+              <a:t>3 minutes. Exit check: identify keyPressed (field), keyPressed() (callback), and key (most recent character), then explain the keyboard-repeat caveat and how this lesson prepares the combined mouse-and-keyboard program in Part 3.</a:t>
+            </a:r>
+            <a:endParaRPr/>
+          </a:p>
+          <a:p xmlns:a="http://schemas.openxmlformats.org/drawingml/2006/main">
+            <a:pPr marL="0" lvl="0" indent="0" algn="l">
+              <a:spcBef>
+                <a:spcPts val="0"/>
+              </a:spcBef>
+              <a:spcAft>
+                <a:spcPts val="0"/>
+              </a:spcAft>
+              <a:buNone/>
+            </a:pPr>
+            <a:r>
+              <a:t/>
+            </a:r>
+            <a:endParaRPr/>
+          </a:p>
+          <a:p xmlns:a="http://schemas.openxmlformats.org/drawingml/2006/main">
+            <a:pPr marL="0" lvl="0" indent="0" algn="l">
+              <a:spcBef>
+                <a:spcPts val="0"/>
+              </a:spcBef>
+              <a:spcAft>
+                <a:spcPts val="0"/>
+              </a:spcAft>
+              <a:buNone/>
+            </a:pPr>
+            <a:r>
+              <a:t>[Sources]</a:t>
+            </a:r>
+            <a:endParaRPr/>
+          </a:p>
+          <a:p xmlns:a="http://schemas.openxmlformats.org/drawingml/2006/main">
+            <a:pPr marL="0" lvl="0" indent="0" algn="l">
+              <a:spcBef>
+                <a:spcPts val="0"/>
+              </a:spcBef>
+              <a:spcAft>
+                <a:spcPts val="0"/>
+              </a:spcAft>
+              <a:buNone/>
+            </a:pPr>
+            <a:r>
+              <a:t>- https://processing.org/reference/</a:t>
             </a:r>
             <a:endParaRPr/>
           </a:p>
@@ -1256,7 +1301,7 @@
   </p:cSld>
   <p:clrMap bg1="lt1" tx1="dk1" bg2="dk2" tx2="lt2" accent1="accent1" accent2="accent2" accent3="accent3" accent4="accent4" accent5="accent5" accent6="accent6" hlink="hlink" folHlink="folHlink"/>
   <p:sldLayoutIdLst>
-    <p:sldLayoutId xmlns:r="http://schemas.openxmlformats.org/officeDocument/2006/relationships" id="2147483649" r:id="R57f5fa289a7d426d"/>
+    <p:sldLayoutId xmlns:r="http://schemas.openxmlformats.org/officeDocument/2006/relationships" id="2147483649" r:id="Rb0f79c6eaa5e4c97"/>
   </p:sldLayoutIdLst>
   <p:hf sldNum="0" hdr="0" ftr="0" dt="0"/>
   <p:txStyles>

</xml_diff>